<commit_message>
docs: banner nova versao
</commit_message>
<xml_diff>
--- a/Documentos/Banner/BANNER_FECAP_ADS4_URBANIS.pptx
+++ b/Documentos/Banner/BANNER_FECAP_ADS4_URBANIS.pptx
@@ -21,7 +21,7 @@
       <p:boldItalic r:id="rId7"/>
     </p:embeddedFont>
     <p:embeddedFont>
-      <p:font typeface="Open Sans" panose="020B0606030504020204" pitchFamily="34" charset="0"/>
+      <p:font typeface="Open Sans" pitchFamily="2" charset="0"/>
       <p:regular r:id="rId8"/>
       <p:bold r:id="rId9"/>
       <p:italic r:id="rId10"/>
@@ -273,7 +273,7 @@
       </p15:sldGuideLst>
     </p:ext>
     <p:ext uri="GoogleSlidesCustomDataVersion2">
-      <go:slidesCustomData xmlns="" xmlns:mc="http://schemas.openxmlformats.org/markup-compatibility/2006" xmlns:mv="urn:schemas-microsoft-com:mac:vml" xmlns:c="http://schemas.openxmlformats.org/drawingml/2006/chart" xmlns:dgm="http://schemas.openxmlformats.org/drawingml/2006/diagram" xmlns:o="urn:schemas-microsoft-com:office:office" xmlns:v="urn:schemas-microsoft-com:vml" xmlns:pvml="urn:schemas-microsoft-com:office:powerpoint" xmlns:com="http://schemas.openxmlformats.org/drawingml/2006/compatibility" xmlns:p14="http://schemas.microsoft.com/office/powerpoint/2010/main" xmlns:p15="http://schemas.microsoft.com/office/powerpoint/2012/main" xmlns:ahyp="http://schemas.microsoft.com/office/drawing/2018/hyperlinkcolor" xmlns:go="http://customooxmlschemas.google.com/" r:id="rId13" roundtripDataSignature="AMtx7mi+9yr4mDS8zg5+kfXTqvtBuST67g=="/>
+      <go:slidesCustomData xmlns:go="http://customooxmlschemas.google.com/" xmlns:ahyp="http://schemas.microsoft.com/office/drawing/2018/hyperlinkcolor" xmlns:p15="http://schemas.microsoft.com/office/powerpoint/2012/main" xmlns:p14="http://schemas.microsoft.com/office/powerpoint/2010/main" xmlns:com="http://schemas.openxmlformats.org/drawingml/2006/compatibility" xmlns:pvml="urn:schemas-microsoft-com:office:powerpoint" xmlns:v="urn:schemas-microsoft-com:vml" xmlns:o="urn:schemas-microsoft-com:office:office" xmlns:dgm="http://schemas.openxmlformats.org/drawingml/2006/diagram" xmlns:c="http://schemas.openxmlformats.org/drawingml/2006/chart" xmlns:mv="urn:schemas-microsoft-com:mac:vml" xmlns:mc="http://schemas.openxmlformats.org/markup-compatibility/2006" xmlns="" r:id="rId13" roundtripDataSignature="AMtx7mi+9yr4mDS8zg5+kfXTqvtBuST67g=="/>
     </p:ext>
   </p:extLst>
 </p:presentation>
@@ -12799,7 +12799,7 @@
         </p:nvSpPr>
         <p:spPr>
           <a:xfrm>
-            <a:off x="15353293" y="19675311"/>
+            <a:off x="15336211" y="19796052"/>
             <a:ext cx="12433206" cy="533095"/>
           </a:xfrm>
           <a:prstGeom prst="rect">
@@ -12862,7 +12862,7 @@
                 <a:cs typeface="Inter"/>
                 <a:sym typeface="Inter"/>
               </a:rPr>
-              <a:t>Análise Exploratória por Distrito (Censo 2022)</a:t>
+              <a:t>Distribuição Territorial Multicamada</a:t>
             </a:r>
             <a:endParaRPr dirty="0"/>
           </a:p>
@@ -12876,8 +12876,8 @@
         </p:nvSpPr>
         <p:spPr>
           <a:xfrm>
-            <a:off x="15353293" y="28652305"/>
-            <a:ext cx="12433206" cy="533095"/>
+            <a:off x="15484945" y="28924345"/>
+            <a:ext cx="12433206" cy="1066189"/>
           </a:xfrm>
           <a:prstGeom prst="rect">
             <a:avLst/>
@@ -12905,6 +12905,29 @@
               </a:spcAft>
               <a:buNone/>
             </a:pPr>
+            <a:endParaRPr lang="en-US" sz="3430" dirty="0">
+              <a:solidFill>
+                <a:srgbClr val="000000"/>
+              </a:solidFill>
+              <a:latin typeface="Inter"/>
+              <a:ea typeface="Inter"/>
+              <a:cs typeface="Inter"/>
+              <a:sym typeface="Inter"/>
+            </a:endParaRPr>
+          </a:p>
+          <a:p>
+            <a:pPr marL="0" marR="0" lvl="0" indent="0" algn="ctr" rtl="0">
+              <a:lnSpc>
+                <a:spcPct val="101020"/>
+              </a:lnSpc>
+              <a:spcBef>
+                <a:spcPts val="0"/>
+              </a:spcBef>
+              <a:spcAft>
+                <a:spcPts val="0"/>
+              </a:spcAft>
+              <a:buNone/>
+            </a:pPr>
             <a:r>
               <a:rPr lang="en-US" sz="3430" dirty="0">
                 <a:solidFill>
@@ -12918,7 +12941,7 @@
               <a:t>Fonte: </a:t>
             </a:r>
             <a:r>
-              <a:rPr lang="en-US" sz="3430" dirty="0" err="1">
+              <a:rPr lang="pt-BR" sz="3430" dirty="0" err="1">
                 <a:solidFill>
                   <a:srgbClr val="000000"/>
                 </a:solidFill>
@@ -12927,10 +12950,10 @@
                 <a:cs typeface="Inter"/>
                 <a:sym typeface="Inter"/>
               </a:rPr>
-              <a:t>Autoria</a:t>
+              <a:t>Urbanis</a:t>
             </a:r>
             <a:r>
-              <a:rPr lang="en-US" sz="3430" dirty="0">
+              <a:rPr lang="pt-BR" sz="3430" dirty="0">
                 <a:solidFill>
                   <a:srgbClr val="000000"/>
                 </a:solidFill>
@@ -12939,31 +12962,7 @@
                 <a:cs typeface="Inter"/>
                 <a:sym typeface="Inter"/>
               </a:rPr>
-              <a:t> </a:t>
-            </a:r>
-            <a:r>
-              <a:rPr lang="en-US" sz="3430" dirty="0" err="1">
-                <a:solidFill>
-                  <a:srgbClr val="000000"/>
-                </a:solidFill>
-                <a:latin typeface="Inter"/>
-                <a:ea typeface="Inter"/>
-                <a:cs typeface="Inter"/>
-                <a:sym typeface="Inter"/>
-              </a:rPr>
-              <a:t>Própria</a:t>
-            </a:r>
-            <a:r>
-              <a:rPr lang="en-US" sz="3430" dirty="0">
-                <a:solidFill>
-                  <a:srgbClr val="000000"/>
-                </a:solidFill>
-                <a:latin typeface="Inter"/>
-                <a:ea typeface="Inter"/>
-                <a:cs typeface="Inter"/>
-                <a:sym typeface="Inter"/>
-              </a:rPr>
-              <a:t> (2026)</a:t>
+              <a:t>. Elaboração a partir de dados públicos</a:t>
             </a:r>
             <a:endParaRPr dirty="0"/>
           </a:p>
@@ -13007,7 +13006,7 @@
               <a:buNone/>
             </a:pPr>
             <a:r>
-              <a:rPr lang="en-US" sz="4762" b="1">
+              <a:rPr lang="en-US" sz="4762" b="1" dirty="0">
                 <a:solidFill>
                   <a:srgbClr val="000000"/>
                 </a:solidFill>
@@ -13018,7 +13017,7 @@
               </a:rPr>
               <a:t>TECNOLOGIAS UTILIZADAS</a:t>
             </a:r>
-            <a:endParaRPr/>
+            <a:endParaRPr dirty="0"/>
           </a:p>
         </p:txBody>
       </p:sp>
@@ -13190,7 +13189,7 @@
         <p:spPr>
           <a:xfrm>
             <a:off x="15966975" y="31719851"/>
-            <a:ext cx="11400000" cy="5474512"/>
+            <a:ext cx="11400000" cy="5172891"/>
           </a:xfrm>
           <a:prstGeom prst="rect">
             <a:avLst/>
@@ -13218,36 +13217,8 @@
                 <a:cs typeface="Open Sans"/>
                 <a:sym typeface="Open Sans"/>
               </a:rPr>
-              <a:t>I</a:t>
+              <a:t>IBGE. Censo Demográfico 2022.</a:t>
             </a:r>
-            <a:r>
-              <a:rPr lang="pt-BR" sz="3430" dirty="0">
-                <a:solidFill>
-                  <a:srgbClr val="000000"/>
-                </a:solidFill>
-                <a:latin typeface="Open Sans"/>
-                <a:ea typeface="Open Sans"/>
-                <a:cs typeface="Open Sans"/>
-                <a:sym typeface="Open Sans"/>
-              </a:rPr>
-              <a:t>BGE. Censo Demográfico 2022. </a:t>
-            </a:r>
-          </a:p>
-          <a:p>
-            <a:pPr lvl="0" algn="just">
-              <a:lnSpc>
-                <a:spcPct val="140000"/>
-              </a:lnSpc>
-            </a:pPr>
-            <a:endParaRPr lang="pt-BR" sz="3430" dirty="0">
-              <a:solidFill>
-                <a:srgbClr val="000000"/>
-              </a:solidFill>
-              <a:latin typeface="Open Sans"/>
-              <a:ea typeface="Open Sans"/>
-              <a:cs typeface="Open Sans"/>
-              <a:sym typeface="Open Sans"/>
-            </a:endParaRPr>
           </a:p>
           <a:p>
             <a:pPr lvl="0" algn="just">
@@ -13257,15 +13228,12 @@
             </a:pPr>
             <a:r>
               <a:rPr lang="pt-BR" sz="3430" dirty="0">
-                <a:solidFill>
-                  <a:srgbClr val="000000"/>
-                </a:solidFill>
                 <a:latin typeface="Open Sans"/>
                 <a:ea typeface="Open Sans"/>
                 <a:cs typeface="Open Sans"/>
                 <a:sym typeface="Open Sans"/>
               </a:rPr>
-              <a:t>SEADE. Indicadores Socioeconômicos do Estado de São Paulo.</a:t>
+              <a:t>IPVS. Índice Paulista de Vulnerabilidade Social.</a:t>
             </a:r>
           </a:p>
           <a:p>
@@ -13274,15 +13242,15 @@
                 <a:spcPct val="140000"/>
               </a:lnSpc>
             </a:pPr>
-            <a:endParaRPr lang="pt-BR" sz="3430" dirty="0">
-              <a:solidFill>
-                <a:srgbClr val="000000"/>
-              </a:solidFill>
-              <a:latin typeface="Open Sans"/>
-              <a:ea typeface="Open Sans"/>
-              <a:cs typeface="Open Sans"/>
-              <a:sym typeface="Open Sans"/>
-            </a:endParaRPr>
+            <a:r>
+              <a:rPr lang="pt-BR" sz="3430" dirty="0">
+                <a:latin typeface="Open Sans"/>
+                <a:ea typeface="Open Sans"/>
+                <a:cs typeface="Open Sans"/>
+                <a:sym typeface="Open Sans"/>
+              </a:rPr>
+              <a:t>SSP-SP. Estatísticas Criminais do Estado de São Paulo.</a:t>
+            </a:r>
           </a:p>
           <a:p>
             <a:pPr lvl="0" algn="just">
@@ -13306,7 +13274,7 @@
                 <a:cs typeface="Open Sans"/>
                 <a:sym typeface="Open Sans"/>
               </a:rPr>
-              <a:t>. Base de dados geoespaciais do município de São Paulo.</a:t>
+              <a:t>. Base de Dados Geoespaciais do Município de São Paulo.</a:t>
             </a:r>
           </a:p>
           <a:p>
@@ -13315,6 +13283,15 @@
                 <a:spcPct val="140000"/>
               </a:lnSpc>
             </a:pPr>
+            <a:r>
+              <a:rPr lang="pt-BR" sz="3430" dirty="0">
+                <a:latin typeface="Open Sans"/>
+                <a:ea typeface="Open Sans"/>
+                <a:cs typeface="Open Sans"/>
+                <a:sym typeface="Open Sans"/>
+              </a:rPr>
+              <a:t>Metrô de São Paulo. Fluxo de Passageiros e Infraestrutura Metroferroviária.</a:t>
+            </a:r>
             <a:endParaRPr dirty="0"/>
           </a:p>
         </p:txBody>
@@ -13344,7 +13321,7 @@
           </a:bodyPr>
           <a:lstStyle/>
           <a:p>
-            <a:pPr marL="0" marR="0" lvl="0" indent="0" algn="just" rtl="0">
+            <a:pPr marL="827496" marR="0" lvl="1" indent="-457200" algn="just" rtl="0">
               <a:lnSpc>
                 <a:spcPct val="140000"/>
               </a:lnSpc>
@@ -13354,63 +13331,11 @@
               <a:spcAft>
                 <a:spcPts val="0"/>
               </a:spcAft>
-              <a:buNone/>
-            </a:pPr>
-            <a:r>
-              <a:rPr lang="pt-BR" sz="3430" dirty="0">
-                <a:solidFill>
-                  <a:srgbClr val="000000"/>
-                </a:solidFill>
-                <a:latin typeface="Open Sans"/>
-                <a:ea typeface="Open Sans"/>
-                <a:cs typeface="Open Sans"/>
-                <a:sym typeface="Open Sans"/>
-              </a:rPr>
-              <a:t>O projeto foi desenvolvido utilizando Python como linguagem principal, com apoio de bibliotecas para análise e visualização de dados, além de plataformas interativas para construção do protótipo.</a:t>
-            </a:r>
-            <a:endParaRPr lang="pt-BR" dirty="0">
-              <a:ea typeface="Open Sans"/>
-            </a:endParaRPr>
-          </a:p>
-          <a:p>
-            <a:pPr marL="0" marR="0" lvl="0" indent="0" algn="just" rtl="0">
-              <a:lnSpc>
-                <a:spcPct val="140000"/>
-              </a:lnSpc>
-              <a:spcBef>
-                <a:spcPts val="0"/>
-              </a:spcBef>
-              <a:spcAft>
-                <a:spcPts val="0"/>
-              </a:spcAft>
-              <a:buNone/>
-            </a:pPr>
-            <a:endParaRPr lang="pt-BR" sz="3430" dirty="0">
-              <a:solidFill>
+              <a:buClr>
                 <a:srgbClr val="000000"/>
-              </a:solidFill>
-              <a:latin typeface="Open Sans"/>
-              <a:ea typeface="Open Sans"/>
-              <a:cs typeface="Open Sans"/>
-              <a:sym typeface="Open Sans"/>
-            </a:endParaRPr>
-          </a:p>
-          <a:p>
-            <a:pPr marL="740593" marR="0" lvl="1" indent="-370297" algn="just" rtl="0">
-              <a:lnSpc>
-                <a:spcPct val="140000"/>
-              </a:lnSpc>
-              <a:spcBef>
-                <a:spcPts val="0"/>
-              </a:spcBef>
-              <a:spcAft>
-                <a:spcPts val="0"/>
-              </a:spcAft>
-              <a:buClr>
-                <a:srgbClr val="000000"/>
               </a:buClr>
               <a:buSzPts val="3430"/>
-              <a:buFont typeface="Arial"/>
+              <a:buFont typeface="Arial" panose="020B0604020202020204" pitchFamily="34" charset="0"/>
               <a:buChar char="•"/>
             </a:pPr>
             <a:r>
@@ -13424,6 +13349,62 @@
                 <a:sym typeface="Open Sans"/>
               </a:rPr>
               <a:t>Python</a:t>
+            </a:r>
+          </a:p>
+          <a:p>
+            <a:pPr marL="827496" marR="0" lvl="1" indent="-457200" algn="just" rtl="0">
+              <a:lnSpc>
+                <a:spcPct val="140000"/>
+              </a:lnSpc>
+              <a:spcBef>
+                <a:spcPts val="0"/>
+              </a:spcBef>
+              <a:spcAft>
+                <a:spcPts val="0"/>
+              </a:spcAft>
+              <a:buClr>
+                <a:srgbClr val="000000"/>
+              </a:buClr>
+              <a:buSzPts val="3430"/>
+              <a:buFont typeface="Arial" panose="020B0604020202020204" pitchFamily="34" charset="0"/>
+              <a:buChar char="•"/>
+            </a:pPr>
+            <a:r>
+              <a:rPr lang="en-US" sz="3430" dirty="0">
+                <a:latin typeface="Open Sans"/>
+                <a:ea typeface="Open Sans"/>
+                <a:cs typeface="Open Sans"/>
+                <a:sym typeface="Open Sans"/>
+              </a:rPr>
+              <a:t>React</a:t>
+            </a:r>
+          </a:p>
+          <a:p>
+            <a:pPr marL="827496" marR="0" lvl="1" indent="-457200" algn="just" rtl="0">
+              <a:lnSpc>
+                <a:spcPct val="140000"/>
+              </a:lnSpc>
+              <a:spcBef>
+                <a:spcPts val="0"/>
+              </a:spcBef>
+              <a:spcAft>
+                <a:spcPts val="0"/>
+              </a:spcAft>
+              <a:buClr>
+                <a:srgbClr val="000000"/>
+              </a:buClr>
+              <a:buSzPts val="3430"/>
+              <a:buFont typeface="Arial" panose="020B0604020202020204" pitchFamily="34" charset="0"/>
+              <a:buChar char="•"/>
+            </a:pPr>
+            <a:r>
+              <a:rPr lang="en-US" sz="3430" dirty="0" err="1">
+                <a:latin typeface="Open Sans"/>
+                <a:ea typeface="Open Sans"/>
+                <a:cs typeface="Open Sans"/>
+                <a:sym typeface="Open Sans"/>
+              </a:rPr>
+              <a:t>TailwindCSS</a:t>
             </a:r>
             <a:endParaRPr dirty="0"/>
           </a:p>
@@ -13489,7 +13470,102 @@
               </a:rPr>
               <a:t>Pandas</a:t>
             </a:r>
-            <a:endParaRPr dirty="0"/>
+          </a:p>
+          <a:p>
+            <a:pPr marL="740593" marR="0" lvl="1" indent="-370297" algn="just" rtl="0">
+              <a:lnSpc>
+                <a:spcPct val="140000"/>
+              </a:lnSpc>
+              <a:spcBef>
+                <a:spcPts val="0"/>
+              </a:spcBef>
+              <a:spcAft>
+                <a:spcPts val="0"/>
+              </a:spcAft>
+              <a:buClr>
+                <a:srgbClr val="000000"/>
+              </a:buClr>
+              <a:buSzPts val="3430"/>
+              <a:buFont typeface="Arial"/>
+              <a:buChar char="•"/>
+            </a:pPr>
+            <a:r>
+              <a:rPr lang="en-US" sz="3430" dirty="0" err="1">
+                <a:latin typeface="Open Sans"/>
+                <a:ea typeface="Open Sans"/>
+                <a:cs typeface="Open Sans"/>
+                <a:sym typeface="Open Sans"/>
+              </a:rPr>
+              <a:t>Ploty</a:t>
+            </a:r>
+            <a:endParaRPr lang="en-US" sz="3430" dirty="0">
+              <a:latin typeface="Open Sans"/>
+              <a:ea typeface="Open Sans"/>
+              <a:cs typeface="Open Sans"/>
+              <a:sym typeface="Open Sans"/>
+            </a:endParaRPr>
+          </a:p>
+          <a:p>
+            <a:pPr marL="740593" marR="0" lvl="1" indent="-370297" algn="just" rtl="0">
+              <a:lnSpc>
+                <a:spcPct val="140000"/>
+              </a:lnSpc>
+              <a:spcBef>
+                <a:spcPts val="0"/>
+              </a:spcBef>
+              <a:spcAft>
+                <a:spcPts val="0"/>
+              </a:spcAft>
+              <a:buClr>
+                <a:srgbClr val="000000"/>
+              </a:buClr>
+              <a:buSzPts val="3430"/>
+              <a:buFont typeface="Arial"/>
+              <a:buChar char="•"/>
+            </a:pPr>
+            <a:r>
+              <a:rPr lang="en-US" sz="3430" dirty="0" err="1">
+                <a:latin typeface="Open Sans"/>
+                <a:ea typeface="Open Sans"/>
+                <a:cs typeface="Open Sans"/>
+                <a:sym typeface="Open Sans"/>
+              </a:rPr>
+              <a:t>GeoJSON</a:t>
+            </a:r>
+            <a:endParaRPr lang="en-US" sz="3430" dirty="0">
+              <a:latin typeface="Open Sans"/>
+              <a:ea typeface="Open Sans"/>
+              <a:cs typeface="Open Sans"/>
+              <a:sym typeface="Open Sans"/>
+            </a:endParaRPr>
+          </a:p>
+          <a:p>
+            <a:pPr marL="740593" marR="0" lvl="1" indent="-370297" algn="just" rtl="0">
+              <a:lnSpc>
+                <a:spcPct val="140000"/>
+              </a:lnSpc>
+              <a:spcBef>
+                <a:spcPts val="0"/>
+              </a:spcBef>
+              <a:spcAft>
+                <a:spcPts val="0"/>
+              </a:spcAft>
+              <a:buClr>
+                <a:srgbClr val="000000"/>
+              </a:buClr>
+              <a:buSzPts val="3430"/>
+              <a:buFont typeface="Arial"/>
+              <a:buChar char="•"/>
+            </a:pPr>
+            <a:r>
+              <a:rPr lang="en-US" sz="3430" dirty="0">
+                <a:latin typeface="Open Sans"/>
+                <a:ea typeface="Open Sans"/>
+                <a:cs typeface="Open Sans"/>
+                <a:sym typeface="Open Sans"/>
+              </a:rPr>
+              <a:t>Shapely</a:t>
+            </a:r>
           </a:p>
         </p:txBody>
       </p:sp>
@@ -13502,7 +13578,7 @@
         <p:spPr>
           <a:xfrm>
             <a:off x="1595870" y="10749184"/>
-            <a:ext cx="12562800" cy="7389844"/>
+            <a:ext cx="12562800" cy="8128828"/>
           </a:xfrm>
           <a:prstGeom prst="rect">
             <a:avLst/>
@@ -13540,7 +13616,7 @@
                 <a:cs typeface="Open Sans"/>
                 <a:sym typeface="Open Sans"/>
               </a:rPr>
-              <a:t>A análise de dados urbanos ainda representa um desafio para empresas e gestores públicos. Embora existam diversas fontes como IBGE e órgãos estaduais, essas informações são dispersas, técnicas e pouco acessíveis para interpretação prática.</a:t>
+              <a:t>A análise territorial ainda representa um desafio para empresas e gestores públicos. Embora existam bases relevantes produzidas por instituições como IBGE, SEADE, SSP-SP, os dados permanecem dispersos, técnicos e de difícil interpretação integrada. </a:t>
             </a:r>
           </a:p>
           <a:p>
@@ -13557,6 +13633,9 @@
               <a:buNone/>
             </a:pPr>
             <a:endParaRPr lang="pt-BR" sz="3430" dirty="0">
+              <a:solidFill>
+                <a:srgbClr val="000000"/>
+              </a:solidFill>
               <a:latin typeface="Open Sans"/>
               <a:ea typeface="Open Sans"/>
               <a:cs typeface="Open Sans"/>
@@ -13586,7 +13665,7 @@
                 <a:cs typeface="Open Sans"/>
                 <a:sym typeface="Open Sans"/>
               </a:rPr>
-              <a:t>Na maioria dos casos, decisões territoriais são tomadas sem o apoio de análises estruturadas, o que aumenta a incerteza e dificulta a comparação entre regiões, limitando o uso estratégico dos dados disponíveis.</a:t>
+              <a:t>Como consequência, decisões relacionadas à expansão comercial, planejamento urbano e análise regional frequentemente são realizadas sem apoio analítico estruturado, dificultando comparações entre diferentes territórios e reduzindo o aproveitamento estratégico</a:t>
             </a:r>
             <a:endParaRPr lang="en-US" sz="3430" dirty="0">
               <a:solidFill>
@@ -13609,7 +13688,7 @@
         <p:spPr>
           <a:xfrm>
             <a:off x="1570066" y="21125709"/>
-            <a:ext cx="12562800" cy="7389844"/>
+            <a:ext cx="12562800" cy="8867812"/>
           </a:xfrm>
           <a:prstGeom prst="rect">
             <a:avLst/>
@@ -13647,7 +13726,7 @@
                 <a:cs typeface="Open Sans"/>
                 <a:sym typeface="Open Sans"/>
               </a:rPr>
-              <a:t>Diante desse cenário, a </a:t>
+              <a:t>A </a:t>
             </a:r>
             <a:r>
               <a:rPr lang="pt-BR" sz="3430" dirty="0" err="1">
@@ -13671,7 +13750,7 @@
                 <a:cs typeface="Open Sans"/>
                 <a:sym typeface="Open Sans"/>
               </a:rPr>
-              <a:t> propõe a construção de um indicador exploratório denominado </a:t>
+              <a:t> propõe uma plataforma de inteligência territorial baseada no </a:t>
             </a:r>
             <a:r>
               <a:rPr lang="pt-BR" sz="3430" dirty="0" err="1">
@@ -13695,7 +13774,7 @@
                 <a:cs typeface="Open Sans"/>
                 <a:sym typeface="Open Sans"/>
               </a:rPr>
-              <a:t>, capaz de sintetizar diferentes características urbanas em uma métrica comparável entre regiões.</a:t>
+              <a:t>, um modelo analítico multicritério capaz de integrar indicadores urbanos, demográficos, econômicos e de mobilidade em uma métrica comparável entre distritos da cidade de São Paulo. </a:t>
             </a:r>
           </a:p>
           <a:p>
@@ -13741,17 +13820,29 @@
                 <a:cs typeface="Open Sans"/>
                 <a:sym typeface="Open Sans"/>
               </a:rPr>
-              <a:t>O modelo combina variáveis como densidade demográfica e uma aproximação de infraestrutura urbana, permitindo gerar uma visão integrada do território. A proposta é reduzir a complexidade dos dados e apoiar análises comparativas, sem caráter decisório.</a:t>
+              <a:t>O sistema combina variáveis como densidade demográfica, fluxo metroferroviário, centralidade econômica, criminalidade e vulnerabilidade social. </a:t>
             </a:r>
-            <a:endParaRPr sz="3430" dirty="0">
-              <a:solidFill>
-                <a:srgbClr val="000000"/>
-              </a:solidFill>
-              <a:latin typeface="Open Sans"/>
-              <a:ea typeface="Open Sans"/>
-              <a:cs typeface="Open Sans"/>
-              <a:sym typeface="Open Sans"/>
-            </a:endParaRPr>
+            <a:r>
+              <a:rPr lang="pt-BR" sz="3430" dirty="0">
+                <a:latin typeface="Open Sans"/>
+                <a:ea typeface="Open Sans"/>
+                <a:cs typeface="Open Sans"/>
+                <a:sym typeface="Open Sans"/>
+              </a:rPr>
+              <a:t>P</a:t>
+            </a:r>
+            <a:r>
+              <a:rPr lang="pt-BR" sz="3430" dirty="0">
+                <a:solidFill>
+                  <a:srgbClr val="000000"/>
+                </a:solidFill>
+                <a:latin typeface="Open Sans"/>
+                <a:ea typeface="Open Sans"/>
+                <a:cs typeface="Open Sans"/>
+                <a:sym typeface="Open Sans"/>
+              </a:rPr>
+              <a:t>ermitindo análises segmentadas conforme diferentes perfis de negócio. O objetivo é transformar dados públicos em suporte analítico para tomada de decisão territorial e estudos de expansão urbana.</a:t>
+            </a:r>
           </a:p>
         </p:txBody>
       </p:sp>
@@ -13853,7 +13944,7 @@
         <p:spPr>
           <a:xfrm>
             <a:off x="15617816" y="10880630"/>
-            <a:ext cx="11904157" cy="8128828"/>
+            <a:ext cx="11904157" cy="8867812"/>
           </a:xfrm>
           <a:prstGeom prst="rect">
             <a:avLst/>
@@ -13891,7 +13982,7 @@
                 <a:cs typeface="Open Sans"/>
                 <a:sym typeface="Open Sans"/>
               </a:rPr>
-              <a:t>A aplicação do modelo evidenciou variações entre os distritos analisados, principalmente em relação à densidade demográfica. O </a:t>
+              <a:t>A aplicação do </a:t>
             </a:r>
             <a:r>
               <a:rPr lang="pt-BR" sz="3430" dirty="0" err="1">
@@ -13915,22 +14006,20 @@
                 <a:cs typeface="Open Sans"/>
                 <a:sym typeface="Open Sans"/>
               </a:rPr>
-              <a:t> permitiu organizar essas diferenças em uma métrica padronizada, facilitando a comparação entre regiões.</a:t>
+              <a:t> evidenciou diferenças relevantes entre os distritos analisados, demonstrando impactos distintos de mobilidade, densidade urbana, centralidade econômica e fatores de risco sobre o potencial territorial. O modelo permitiu estruturar comparações urbanas mais abrangentes do que análises isoladas de densidade populacional, possibilitando interpretações segmentadas conforme o perfil do negócio analisado. Os resultados possuem caráter exploratório e representam uma etapa inicial de validação do modelo analítico e da proposta de inteligência territorial da </a:t>
             </a:r>
-          </a:p>
-          <a:p>
-            <a:pPr marL="0" marR="0" lvl="0" indent="0" algn="just" rtl="0">
-              <a:lnSpc>
-                <a:spcPct val="140000"/>
-              </a:lnSpc>
-              <a:spcBef>
-                <a:spcPts val="0"/>
-              </a:spcBef>
-              <a:spcAft>
-                <a:spcPts val="0"/>
-              </a:spcAft>
-              <a:buNone/>
-            </a:pPr>
+            <a:r>
+              <a:rPr lang="pt-BR" sz="3430" dirty="0" err="1">
+                <a:solidFill>
+                  <a:srgbClr val="000000"/>
+                </a:solidFill>
+                <a:latin typeface="Open Sans"/>
+                <a:ea typeface="Open Sans"/>
+                <a:cs typeface="Open Sans"/>
+                <a:sym typeface="Open Sans"/>
+              </a:rPr>
+              <a:t>Urbanis</a:t>
+            </a:r>
             <a:r>
               <a:rPr lang="pt-BR" sz="3430" dirty="0">
                 <a:solidFill>
@@ -13941,7 +14030,7 @@
                 <a:cs typeface="Open Sans"/>
                 <a:sym typeface="Open Sans"/>
               </a:rPr>
-              <a:t>Observa-se que distritos mais densos tendem a apresentar valores mais elevados no indicador, enquanto regiões com menor densidade apresentam valores inferiores dentro da distribuição analisada. Os resultados possuem caráter exploratório e refletem exclusivamente as variáveis consideradas no modelo.</a:t>
+              <a:t>.</a:t>
             </a:r>
             <a:endParaRPr lang="en-US" dirty="0"/>
           </a:p>
@@ -14165,10 +14254,10 @@
       </p:sp>
       <p:pic>
         <p:nvPicPr>
-          <p:cNvPr id="7" name="Imagem 6">
+          <p:cNvPr id="4" name="Imagem 3">
             <a:extLst>
               <a:ext uri="{FF2B5EF4-FFF2-40B4-BE49-F238E27FC236}">
-                <a16:creationId xmlns:a16="http://schemas.microsoft.com/office/drawing/2014/main" id="{919CAC44-FA23-DF91-8B08-BF28480EC96A}"/>
+                <a16:creationId xmlns:a16="http://schemas.microsoft.com/office/drawing/2014/main" id="{1C8C367D-0827-07A3-FB46-E0833DF3DBFB}"/>
               </a:ext>
             </a:extLst>
           </p:cNvPr>
@@ -14185,8 +14274,8 @@
         </p:blipFill>
         <p:spPr>
           <a:xfrm>
-            <a:off x="15338739" y="20868912"/>
-            <a:ext cx="12447789" cy="7421343"/>
+            <a:off x="15617815" y="20520644"/>
+            <a:ext cx="11993386" cy="8693191"/>
           </a:xfrm>
           <a:prstGeom prst="rect">
             <a:avLst/>

</xml_diff>